<commit_message>
Polish MKT1107 Buổi 5–7 wrapping; balance reference pages
Co-Authored-By: Claude Opus 5.5 <noreply@anthropic.com>
Claude-Session: https://claude.ai/code/session_01Nw7HpGarY4JnDFYKKuarvZ
</commit_message>
<xml_diff>
--- a/mkt1107/output/MKT1107_W05_slides.pptx
+++ b/mkt1107/output/MKT1107_W05_slides.pptx
@@ -153,19 +153,19 @@
   <p:extLst>
     <p:ext uri="{521415D9-36F7-43E2-AB2F-B90AF26B5E84}">
       <p14:sectionLst xmlns:p14="http://schemas.microsoft.com/office/powerpoint/2010/main">
-        <p14:section name="Mở đầu" id="{4dd10b96-1f97-ba25-c645-a0c0cbd74577}">
+        <p14:section name="Mở đầu" id="{b2bb7107-ca93-e228-788e-ca33d51d884d}">
           <p14:sldIdLst>
             <p14:sldId id="256"/>
           </p14:sldIdLst>
         </p14:section>
-        <p14:section name="S1 · Khởi động: AI đã bịa bao nhiêu trích dẫn?" id="{9859743e-d2f3-191b-addf-380a87ec2990}">
+        <p14:section name="S1 · Khởi động: AI đã bịa bao nhiêu trích dẫn?" id="{ca3ddbb5-5d6d-6c0c-9af9-3e02f5313c0f}">
           <p14:sldIdLst>
             <p14:sldId id="257"/>
             <p14:sldId id="258"/>
             <p14:sldId id="259"/>
           </p14:sldIdLst>
         </p14:section>
-        <p14:section name="S2 · 3.5 Ưu điểm và hạn chế của AI" id="{1b16bf45-9079-07f3-808c-7aef39467405}">
+        <p14:section name="S2 · 3.5 Ưu điểm và hạn chế của AI" id="{453c5e7c-5235-1da2-d5ad-8a38984e8375}">
           <p14:sldIdLst>
             <p14:sldId id="260"/>
             <p14:sldId id="261"/>
@@ -178,7 +178,7 @@
             <p14:sldId id="268"/>
           </p14:sldIdLst>
         </p14:section>
-        <p14:section name="S3 · 3.6 Ứng dụng của AI" id="{a0a67a70-75bf-5fb6-5569-c5364d20b840}">
+        <p14:section name="S3 · 3.6 Ứng dụng của AI" id="{a1ba014b-5e7d-47da-ee68-d887512964bb}">
           <p14:sldIdLst>
             <p14:sldId id="269"/>
             <p14:sldId id="270"/>
@@ -190,7 +190,7 @@
             <p14:sldId id="276"/>
           </p14:sldIdLst>
         </p14:section>
-        <p14:section name="S4 · 3.7 Công cụ AI hỗ trợ nghiên cứu" id="{dbb04932-169f-c237-64f1-082ebf62f3a8}">
+        <p14:section name="S4 · 3.7 Công cụ AI hỗ trợ nghiên cứu" id="{8299a3fa-bc86-fde5-08ad-70160202fdc9}">
           <p14:sldIdLst>
             <p14:sldId id="277"/>
             <p14:sldId id="278"/>
@@ -199,7 +199,7 @@
             <p14:sldId id="281"/>
           </p14:sldIdLst>
         </p14:section>
-        <p14:section name="S5 · 3.8 Cách đặt câu lệnh (prompt) hỗ trợ nghiên cứu" id="{4ada15d9-df85-aae6-ea5b-4b43bcd4b3b2}">
+        <p14:section name="S5 · 3.8 Cách đặt câu lệnh (prompt) hỗ trợ nghiên cứu" id="{430f0bc1-d79f-d7dd-bfe2-724f6ca22816}">
           <p14:sldIdLst>
             <p14:sldId id="282"/>
             <p14:sldId id="283"/>
@@ -212,7 +212,7 @@
             <p14:sldId id="290"/>
           </p14:sldIdLst>
         </p14:section>
-        <p14:section name="S6 · Đạo đức, quy định dùng AI và trích dẫn AI" id="{76acc979-d075-b1d2-50a1-5ae61df37e1f}">
+        <p14:section name="S6 · Đạo đức, quy định dùng AI và trích dẫn AI" id="{0d92188f-3c2c-b319-2e10-48aba829eaab}">
           <p14:sldIdLst>
             <p14:sldId id="291"/>
             <p14:sldId id="292"/>
@@ -221,13 +221,13 @@
             <p14:sldId id="295"/>
           </p14:sldIdLst>
         </p14:section>
-        <p14:section name="S7 · Thực hành nhóm: Xưởng câu lệnh" id="{74f04395-c16a-7ada-3084-68a8e600ccf7}">
+        <p14:section name="S7 · Thực hành nhóm: Xưởng câu lệnh" id="{aa654262-d6ec-cb74-ed3c-81662f9d3e75}">
           <p14:sldIdLst>
             <p14:sldId id="296"/>
             <p14:sldId id="297"/>
           </p14:sldIdLst>
         </p14:section>
-        <p14:section name="S8 · Kết buổi" id="{f48ad6e4-581b-e499-0130-2e8f0962f07a}">
+        <p14:section name="S8 · Kết buổi" id="{667651fe-bb1b-ae5b-ef27-610ddd0953b7}">
           <p14:sldIdLst>
             <p14:sldId id="298"/>
             <p14:sldId id="299"/>
@@ -8506,7 +8506,7 @@
                           <a:ea typeface="Alexandria" pitchFamily="34" charset="-122"/>
                           <a:cs typeface="Alexandria" pitchFamily="34" charset="-120"/>
                         </a:rPr>
-                        <a:t>Khai báo công cụ, mục đích; nộp nhật ký AI</a:t>
+                        <a:t>Khai báo công cụ, mục đích; nộp nhật ký AI</a:t>
                       </a:r>
                       <a:endParaRPr lang="en-US" sz="2400" dirty="0">
                         <a:latin typeface="Alexandria" charset="0"/>
@@ -8579,7 +8579,7 @@
                           <a:ea typeface="Alexandria" pitchFamily="34" charset="-122"/>
                           <a:cs typeface="Alexandria" pitchFamily="34" charset="-120"/>
                         </a:rPr>
-                        <a:t>Kiểm tra thuật toán định kỳ</a:t>
+                        <a:t>Kiểm tra thuật toán định kỳ</a:t>
                       </a:r>
                       <a:endParaRPr lang="en-US" sz="2400" dirty="0">
                         <a:latin typeface="Alexandria" charset="0"/>
@@ -12676,7 +12676,7 @@
       </p:sp>
       <p:sp>
         <p:nvSpPr>
-          <p:cNvPr id="11" name="Thẻ Phân tích dự báo"/>
+          <p:cNvPr id="11" name="Thẻ Phân tích dự báo"/>
           <p:cNvSpPr/>
           <p:nvPr/>
         </p:nvSpPr>
@@ -12791,7 +12791,7 @@
                 <a:ea typeface="Alexandria" pitchFamily="34" charset="-122"/>
                 <a:cs typeface="Alexandria" pitchFamily="34" charset="-120"/>
               </a:rPr>
-              <a:t>Phân tích dự báo</a:t>
+              <a:t>Phân tích dự báo</a:t>
             </a:r>
             <a:endParaRPr lang="en-US" sz="2800" dirty="0"/>
           </a:p>
@@ -13121,7 +13121,7 @@
                 <a:ea typeface="Alexandria" pitchFamily="34" charset="-122"/>
                 <a:cs typeface="Alexandria" pitchFamily="34" charset="-120"/>
               </a:rPr>
-              <a:t>AI phân tích → đề xuất, mô phỏng → doanh nghiệp quyết định</a:t>
+              <a:t>AI phân tích → đề xuất, mô phỏng → doanh nghiệp quyết định</a:t>
             </a:r>
             <a:endParaRPr lang="en-US" sz="2600" dirty="0"/>
           </a:p>
@@ -13382,11 +13382,11 @@
         <p:spPr>
           <a:xfrm>
             <a:off x="502920" y="2697480"/>
-            <a:ext cx="2651760" cy="2423160"/>
+            <a:ext cx="2651760" cy="2037080"/>
           </a:xfrm>
           <a:prstGeom prst="roundRect">
             <a:avLst>
-              <a:gd name="adj" fmla="val 6792"/>
+              <a:gd name="adj" fmla="val 8080"/>
             </a:avLst>
           </a:prstGeom>
           <a:solidFill>
@@ -13463,7 +13463,7 @@
         <p:spPr>
           <a:xfrm>
             <a:off x="548640" y="2743200"/>
-            <a:ext cx="2560320" cy="1076960"/>
+            <a:ext cx="2560320" cy="614680"/>
           </a:xfrm>
           <a:prstGeom prst="rect">
             <a:avLst/>
@@ -13504,8 +13504,8 @@
         </p:nvSpPr>
         <p:spPr>
           <a:xfrm>
-            <a:off x="548640" y="3820160"/>
-            <a:ext cx="2560320" cy="1300480"/>
+            <a:off x="548640" y="3357880"/>
+            <a:ext cx="2560320" cy="1376680"/>
           </a:xfrm>
           <a:prstGeom prst="rect">
             <a:avLst/>
@@ -13547,11 +13547,11 @@
         <p:spPr>
           <a:xfrm>
             <a:off x="3337560" y="2697480"/>
-            <a:ext cx="2651760" cy="2423160"/>
+            <a:ext cx="2651760" cy="2037080"/>
           </a:xfrm>
           <a:prstGeom prst="roundRect">
             <a:avLst>
-              <a:gd name="adj" fmla="val 6792"/>
+              <a:gd name="adj" fmla="val 8080"/>
             </a:avLst>
           </a:prstGeom>
           <a:solidFill>
@@ -13628,7 +13628,7 @@
         <p:spPr>
           <a:xfrm>
             <a:off x="3383280" y="2743200"/>
-            <a:ext cx="2560320" cy="1076960"/>
+            <a:ext cx="2560320" cy="614680"/>
           </a:xfrm>
           <a:prstGeom prst="rect">
             <a:avLst/>
@@ -13669,8 +13669,8 @@
         </p:nvSpPr>
         <p:spPr>
           <a:xfrm>
-            <a:off x="3383280" y="3820160"/>
-            <a:ext cx="2560320" cy="1300480"/>
+            <a:off x="3383280" y="3357880"/>
+            <a:ext cx="2560320" cy="1376680"/>
           </a:xfrm>
           <a:prstGeom prst="rect">
             <a:avLst/>
@@ -13712,11 +13712,11 @@
         <p:spPr>
           <a:xfrm>
             <a:off x="6172200" y="2697480"/>
-            <a:ext cx="2651760" cy="2423160"/>
+            <a:ext cx="2651760" cy="2037080"/>
           </a:xfrm>
           <a:prstGeom prst="roundRect">
             <a:avLst>
-              <a:gd name="adj" fmla="val 6792"/>
+              <a:gd name="adj" fmla="val 8080"/>
             </a:avLst>
           </a:prstGeom>
           <a:solidFill>
@@ -13793,7 +13793,7 @@
         <p:spPr>
           <a:xfrm>
             <a:off x="6217920" y="2743200"/>
-            <a:ext cx="2560320" cy="1076960"/>
+            <a:ext cx="2560320" cy="614680"/>
           </a:xfrm>
           <a:prstGeom prst="rect">
             <a:avLst/>
@@ -13820,7 +13820,7 @@
                 <a:ea typeface="Alexandria" pitchFamily="34" charset="-122"/>
                 <a:cs typeface="Alexandria" pitchFamily="34" charset="-120"/>
               </a:rPr>
-              <a:t>Kiểm tra mẫu</a:t>
+              <a:t>Người kiểm</a:t>
             </a:r>
             <a:endParaRPr lang="en-US" sz="2800" dirty="0"/>
           </a:p>
@@ -13834,8 +13834,8 @@
         </p:nvSpPr>
         <p:spPr>
           <a:xfrm>
-            <a:off x="6217920" y="3820160"/>
-            <a:ext cx="2560320" cy="1300480"/>
+            <a:off x="6217920" y="3357880"/>
+            <a:ext cx="2560320" cy="1376680"/>
           </a:xfrm>
           <a:prstGeom prst="rect">
             <a:avLst/>
@@ -13862,7 +13862,7 @@
                 <a:ea typeface="Alexandria" pitchFamily="34" charset="-122"/>
                 <a:cs typeface="Alexandria" pitchFamily="34" charset="-120"/>
               </a:rPr>
-              <a:t>Đọc vài trăm bình luận</a:t>
+              <a:t>Đọc vài trăm mẫu</a:t>
             </a:r>
             <a:endParaRPr lang="en-US" sz="2600" dirty="0"/>
           </a:p>
@@ -13877,11 +13877,11 @@
         <p:spPr>
           <a:xfrm>
             <a:off x="9006840" y="2697480"/>
-            <a:ext cx="2651760" cy="2423160"/>
+            <a:ext cx="2651760" cy="2037080"/>
           </a:xfrm>
           <a:prstGeom prst="roundRect">
             <a:avLst>
-              <a:gd name="adj" fmla="val 6792"/>
+              <a:gd name="adj" fmla="val 8080"/>
             </a:avLst>
           </a:prstGeom>
           <a:solidFill>
@@ -13958,7 +13958,7 @@
         <p:spPr>
           <a:xfrm>
             <a:off x="9052560" y="2743200"/>
-            <a:ext cx="2560320" cy="1076960"/>
+            <a:ext cx="2560320" cy="614680"/>
           </a:xfrm>
           <a:prstGeom prst="rect">
             <a:avLst/>
@@ -13999,8 +13999,8 @@
         </p:nvSpPr>
         <p:spPr>
           <a:xfrm>
-            <a:off x="9052560" y="3820160"/>
-            <a:ext cx="2560320" cy="1300480"/>
+            <a:off x="9052560" y="3357880"/>
+            <a:ext cx="2560320" cy="1376680"/>
           </a:xfrm>
           <a:prstGeom prst="rect">
             <a:avLst/>
@@ -14041,7 +14041,7 @@
         </p:nvSpPr>
         <p:spPr>
           <a:xfrm>
-            <a:off x="548640" y="5394960"/>
+            <a:off x="548640" y="5100320"/>
             <a:ext cx="11064240" cy="685800"/>
           </a:xfrm>
           <a:prstGeom prst="roundRect">
@@ -14063,7 +14063,7 @@
         </p:nvSpPr>
         <p:spPr>
           <a:xfrm>
-            <a:off x="731520" y="5509260"/>
+            <a:off x="731520" y="5214620"/>
             <a:ext cx="457200" cy="457200"/>
           </a:xfrm>
           <a:prstGeom prst="ellipse">
@@ -14083,7 +14083,7 @@
         </p:nvSpPr>
         <p:spPr>
           <a:xfrm>
-            <a:off x="731520" y="5509260"/>
+            <a:off x="731520" y="5214620"/>
             <a:ext cx="457200" cy="457200"/>
           </a:xfrm>
           <a:prstGeom prst="rect">
@@ -14122,7 +14122,7 @@
         </p:nvSpPr>
         <p:spPr>
           <a:xfrm>
-            <a:off x="1325880" y="5394960"/>
+            <a:off x="1325880" y="5100320"/>
             <a:ext cx="10149840" cy="685800"/>
           </a:xfrm>
           <a:prstGeom prst="rect">
@@ -15462,7 +15462,7 @@
                 <a:ea typeface="Alexandria" pitchFamily="34" charset="-122"/>
                 <a:cs typeface="Alexandria" pitchFamily="34" charset="-120"/>
               </a:rPr>
-              <a:t>Mở sẵn một công cụ AI</a:t>
+              <a:t>Mở sẵn một công cụ AI</a:t>
             </a:r>
             <a:endParaRPr lang="en-US" sz="3000" dirty="0"/>
           </a:p>
@@ -22210,7 +22210,7 @@
       </p:sp>
       <p:sp>
         <p:nvSpPr>
-          <p:cNvPr id="6" name="Thẻ Công cụ, câu lệnh?"/>
+          <p:cNvPr id="6" name="Thẻ Công cụ, câu lệnh?"/>
           <p:cNvSpPr/>
           <p:nvPr/>
         </p:nvSpPr>
@@ -22325,7 +22325,7 @@
                 <a:ea typeface="Alexandria" pitchFamily="34" charset="-122"/>
                 <a:cs typeface="Alexandria" pitchFamily="34" charset="-120"/>
               </a:rPr>
-              <a:t>Công cụ, câu lệnh?</a:t>
+              <a:t>Công cụ, câu lệnh?</a:t>
             </a:r>
             <a:endParaRPr lang="en-US" sz="2800" dirty="0"/>
           </a:p>
@@ -22375,7 +22375,7 @@
       </p:sp>
       <p:sp>
         <p:nvSpPr>
-          <p:cNvPr id="11" name="Thẻ Đúng hay sai?"/>
+          <p:cNvPr id="11" name="Thẻ Đúng hay sai?"/>
           <p:cNvSpPr/>
           <p:nvPr/>
         </p:nvSpPr>
@@ -22490,7 +22490,7 @@
                 <a:ea typeface="Alexandria" pitchFamily="34" charset="-122"/>
                 <a:cs typeface="Alexandria" pitchFamily="34" charset="-120"/>
               </a:rPr>
-              <a:t>Đúng hay sai?</a:t>
+              <a:t>Đúng hay sai?</a:t>
             </a:r>
             <a:endParaRPr lang="en-US" sz="2800" dirty="0"/>
           </a:p>
@@ -23691,7 +23691,7 @@
                           <a:ea typeface="Alexandria" pitchFamily="34" charset="-122"/>
                           <a:cs typeface="Alexandria" pitchFamily="34" charset="-120"/>
                         </a:rPr>
-                        <a:t>: Context – Action – Result – Example</a:t>
+                        <a:t>: Context – Action – Result – Example</a:t>
                       </a:r>
                       <a:endParaRPr lang="en-US" sz="2400" dirty="0">
                         <a:latin typeface="Alexandria" charset="0"/>
@@ -23762,7 +23762,7 @@
                           <a:ea typeface="Alexandria" pitchFamily="34" charset="-122"/>
                           <a:cs typeface="Alexandria" pitchFamily="34" charset="-120"/>
                         </a:rPr>
-                        <a:t>Việc phức tạp, cần đúng mẫu</a:t>
+                        <a:t>Việc phức tạp, cần đúng mẫu</a:t>
                       </a:r>
                       <a:endParaRPr lang="en-US" sz="2400" dirty="0">
                         <a:latin typeface="Alexandria" charset="0"/>
@@ -26419,7 +26419,7 @@
                 <a:ea typeface="Alexandria" pitchFamily="34" charset="-122"/>
                 <a:cs typeface="Alexandria" pitchFamily="34" charset="-120"/>
               </a:rPr>
-              <a:t>8–10 câu hỏi mở, buổi 30 phút</a:t>
+              <a:t>8–10 câu hỏi mở, buổi 30 phút</a:t>
             </a:r>
             <a:endParaRPr lang="en-US" sz="2500" dirty="0"/>
           </a:p>
@@ -26584,7 +26584,7 @@
                 <a:ea typeface="Alexandria" pitchFamily="34" charset="-122"/>
                 <a:cs typeface="Alexandria" pitchFamily="34" charset="-120"/>
               </a:rPr>
-              <a:t>3 phần; mỗi câu có câu gợi mở</a:t>
+              <a:t>3 phần; mỗi câu có câu gợi mở</a:t>
             </a:r>
             <a:endParaRPr lang="en-US" sz="2500" dirty="0"/>
           </a:p>
@@ -34461,7 +34461,7 @@
                 <a:ea typeface="Alexandria" pitchFamily="34" charset="-122"/>
                 <a:cs typeface="Alexandria" pitchFamily="34" charset="-120"/>
               </a:rPr>
-              <a:t>Theo chủ đề · đọc bản gốc · APA 7 · nhật ký AI · khai báo · hướng dự kiến</a:t>
+              <a:t>Theo chủ đề · đọc bản gốc · APA 7 · nhật ký AI · khai báo · hướng dự kiến</a:t>
             </a:r>
             <a:endParaRPr lang="en-US" sz="2600" dirty="0"/>
           </a:p>
@@ -35000,102 +35000,6 @@
       </p:sp>
       <p:sp>
         <p:nvSpPr>
-          <p:cNvPr id="10" name="Dấu đầu dòng"/>
-          <p:cNvSpPr/>
-          <p:nvPr/>
-        </p:nvSpPr>
-        <p:spPr>
-          <a:xfrm>
-            <a:off x="585216" y="4803648"/>
-            <a:ext cx="164592" cy="164592"/>
-          </a:xfrm>
-          <a:prstGeom prst="ellipse">
-            <a:avLst/>
-          </a:prstGeom>
-          <a:solidFill>
-            <a:srgbClr val="49B296"/>
-          </a:solidFill>
-          <a:ln/>
-        </p:spPr>
-      </p:sp>
-      <p:sp>
-        <p:nvSpPr>
-          <p:cNvPr id="11" name="Text 9"/>
-          <p:cNvSpPr txBox="1"/>
-          <p:nvPr/>
-        </p:nvSpPr>
-        <p:spPr>
-          <a:xfrm>
-            <a:off x="914400" y="4611624"/>
-            <a:ext cx="10607040" cy="944880"/>
-          </a:xfrm>
-          <a:prstGeom prst="rect">
-            <a:avLst/>
-          </a:prstGeom>
-          <a:noFill/>
-          <a:ln/>
-        </p:spPr>
-        <p:txBody>
-          <a:bodyPr wrap="square" lIns="76200" tIns="76200" rIns="76200" bIns="76200" rtlCol="0" anchor="t"/>
-          <a:lstStyle/>
-          <a:p>
-            <a:pPr algn="l" indent="0" marL="0">
-              <a:lnSpc>
-                <a:spcPts val="3100"/>
-              </a:lnSpc>
-              <a:buNone/>
-            </a:pPr>
-            <a:r>
-              <a:rPr lang="en-US" sz="2400" dirty="0">
-                <a:solidFill>
-                  <a:srgbClr val="2E2A3A"/>
-                </a:solidFill>
-                <a:latin typeface="Alexandria" pitchFamily="34" charset="0"/>
-                <a:ea typeface="Alexandria" pitchFamily="34" charset="-122"/>
-                <a:cs typeface="Alexandria" pitchFamily="34" charset="-120"/>
-              </a:rPr>
-              <a:t>McAdoo, T. (2023, April 7). </a:t>
-            </a:r>
-            <a:pPr algn="l" indent="0" marL="0">
-              <a:lnSpc>
-                <a:spcPts val="3100"/>
-              </a:lnSpc>
-              <a:buNone/>
-            </a:pPr>
-            <a:r>
-              <a:rPr lang="en-US" sz="2400" i="1" dirty="0">
-                <a:solidFill>
-                  <a:srgbClr val="2E2A3A"/>
-                </a:solidFill>
-                <a:latin typeface="Alexandria" pitchFamily="34" charset="0"/>
-                <a:ea typeface="Alexandria" pitchFamily="34" charset="-122"/>
-                <a:cs typeface="Alexandria" pitchFamily="34" charset="-120"/>
-              </a:rPr>
-              <a:t>How to cite ChatGPT</a:t>
-            </a:r>
-            <a:pPr algn="l" indent="0" marL="0">
-              <a:lnSpc>
-                <a:spcPts val="3100"/>
-              </a:lnSpc>
-              <a:buNone/>
-            </a:pPr>
-            <a:r>
-              <a:rPr lang="en-US" sz="2400" dirty="0">
-                <a:solidFill>
-                  <a:srgbClr val="2E2A3A"/>
-                </a:solidFill>
-                <a:latin typeface="Alexandria" pitchFamily="34" charset="0"/>
-                <a:ea typeface="Alexandria" pitchFamily="34" charset="-122"/>
-                <a:cs typeface="Alexandria" pitchFamily="34" charset="-120"/>
-              </a:rPr>
-              <a:t>. APA Style Blog. https://apastyle.apa.org/blog/how-to-cite-chatgpt</a:t>
-            </a:r>
-            <a:endParaRPr lang="en-US" sz="2400" dirty="0"/>
-          </a:p>
-        </p:txBody>
-      </p:sp>
-      <p:sp>
-        <p:nvSpPr>
           <p:cNvPr id="25" name="Slide Number Placeholder 0"/>
           <p:cNvSpPr>
             <a:spLocks noGrp="1"/>
@@ -35324,6 +35228,102 @@
                 <a:ea typeface="Alexandria" pitchFamily="34" charset="-122"/>
                 <a:cs typeface="Alexandria" pitchFamily="34" charset="-120"/>
               </a:rPr>
+              <a:t>McAdoo, T. (2023, April 7). </a:t>
+            </a:r>
+            <a:pPr algn="l" indent="0" marL="0">
+              <a:lnSpc>
+                <a:spcPts val="3100"/>
+              </a:lnSpc>
+              <a:buNone/>
+            </a:pPr>
+            <a:r>
+              <a:rPr lang="en-US" sz="2400" i="1" dirty="0">
+                <a:solidFill>
+                  <a:srgbClr val="2E2A3A"/>
+                </a:solidFill>
+                <a:latin typeface="Alexandria" pitchFamily="34" charset="0"/>
+                <a:ea typeface="Alexandria" pitchFamily="34" charset="-122"/>
+                <a:cs typeface="Alexandria" pitchFamily="34" charset="-120"/>
+              </a:rPr>
+              <a:t>How to cite ChatGPT</a:t>
+            </a:r>
+            <a:pPr algn="l" indent="0" marL="0">
+              <a:lnSpc>
+                <a:spcPts val="3100"/>
+              </a:lnSpc>
+              <a:buNone/>
+            </a:pPr>
+            <a:r>
+              <a:rPr lang="en-US" sz="2400" dirty="0">
+                <a:solidFill>
+                  <a:srgbClr val="2E2A3A"/>
+                </a:solidFill>
+                <a:latin typeface="Alexandria" pitchFamily="34" charset="0"/>
+                <a:ea typeface="Alexandria" pitchFamily="34" charset="-122"/>
+                <a:cs typeface="Alexandria" pitchFamily="34" charset="-120"/>
+              </a:rPr>
+              <a:t>. APA Style Blog. https://apastyle.apa.org/blog/how-to-cite-chatgpt</a:t>
+            </a:r>
+            <a:endParaRPr lang="en-US" sz="2400" dirty="0"/>
+          </a:p>
+        </p:txBody>
+      </p:sp>
+      <p:sp>
+        <p:nvSpPr>
+          <p:cNvPr id="8" name="Dấu đầu dòng"/>
+          <p:cNvSpPr/>
+          <p:nvPr/>
+        </p:nvSpPr>
+        <p:spPr>
+          <a:xfrm>
+            <a:off x="585216" y="2993136"/>
+            <a:ext cx="164592" cy="164592"/>
+          </a:xfrm>
+          <a:prstGeom prst="ellipse">
+            <a:avLst/>
+          </a:prstGeom>
+          <a:solidFill>
+            <a:srgbClr val="49B296"/>
+          </a:solidFill>
+          <a:ln/>
+        </p:spPr>
+      </p:sp>
+      <p:sp>
+        <p:nvSpPr>
+          <p:cNvPr id="9" name="Text 7"/>
+          <p:cNvSpPr txBox="1"/>
+          <p:nvPr/>
+        </p:nvSpPr>
+        <p:spPr>
+          <a:xfrm>
+            <a:off x="914400" y="2801112"/>
+            <a:ext cx="10607040" cy="944880"/>
+          </a:xfrm>
+          <a:prstGeom prst="rect">
+            <a:avLst/>
+          </a:prstGeom>
+          <a:noFill/>
+          <a:ln/>
+        </p:spPr>
+        <p:txBody>
+          <a:bodyPr wrap="square" lIns="76200" tIns="76200" rIns="76200" bIns="76200" rtlCol="0" anchor="t"/>
+          <a:lstStyle/>
+          <a:p>
+            <a:pPr algn="l" indent="0" marL="0">
+              <a:lnSpc>
+                <a:spcPts val="3100"/>
+              </a:lnSpc>
+              <a:buNone/>
+            </a:pPr>
+            <a:r>
+              <a:rPr lang="en-US" sz="2400" dirty="0">
+                <a:solidFill>
+                  <a:srgbClr val="2E2A3A"/>
+                </a:solidFill>
+                <a:latin typeface="Alexandria" pitchFamily="34" charset="0"/>
+                <a:ea typeface="Alexandria" pitchFamily="34" charset="-122"/>
+                <a:cs typeface="Alexandria" pitchFamily="34" charset="-120"/>
+              </a:rPr>
               <a:t>Russell, S., &amp; Norvig, P. (2021). </a:t>
             </a:r>
             <a:pPr algn="l" indent="0" marL="0">
@@ -36487,7 +36487,7 @@
                 <a:ea typeface="Alexandria" pitchFamily="34" charset="-122"/>
                 <a:cs typeface="Alexandria" pitchFamily="34" charset="-120"/>
               </a:rPr>
-              <a:t>Gợi ý khi nhóm bị bí</a:t>
+              <a:t>Gợi ý khi nhóm bị bí</a:t>
             </a:r>
             <a:endParaRPr lang="en-US" sz="2600" dirty="0"/>
           </a:p>

</xml_diff>